<commit_message>
README rewrite, narrative presentation with spoken script, final audit
- README: how every dataset was obtained (requests, masks, validation), every
  choice with its justification and rejected alternative, the goal, inputs and
  outputs of each script, and a brief-to-answer map
- Presentation restructured as one thread (question -> what the data measure ->
  method -> results -> economy -> claims); new method and crops/rain slides;
  presentation/SCRIPT.md is the spoken script, generated from the same source
  as the speaker notes so numbers cannot drift; slide images numbered as in deck
- Final audit (docs/AUDIT_final.md): full re-run reproduces byte for byte; paper
  tables match generated tables (0 mismatches); fixed rank correlation (0.06),
  France 2003 summer z (3.4), point-correlation labels, requirements (pandas>=2.2,
  markdown), a causal phrase in the talk, and the Atlas log access date
</commit_message>
<xml_diff>
--- a/presentation/Track1_presentation.pptx
+++ b/presentation/Track1_presentation.pptx
@@ -17,6 +17,8 @@
     <p:sldId id="265" r:id="rId17"/>
     <p:sldId id="266" r:id="rId18"/>
     <p:sldId id="267" r:id="rId19"/>
+    <p:sldId id="268" r:id="rId20"/>
+    <p:sldId id="269" r:id="rId21"/>
   </p:sldIdLst>
   <p:sldSz cx="12188952" cy="6858000" type="screen4x3"/>
   <p:notesSz cx="6858000" cy="9144000"/>
@@ -513,7 +515,13 @@
           <a:lstStyle/>
           <a:p>
             <a:r>
-              <a:t>Speaker 1 (0:00-0:30). Introduce the group and the question in one sentence.</a:t>
+              <a:t>[Speaker 1 · 0:00-0:35]</a:t>
+            </a:r>
+          </a:p>
+          <a:p/>
+          <a:p>
+            <a:r>
+              <a:t>Every plan we make, a harvest, a dam, a heating system, assumes that a normal year looks like the normal years we remember. Our question is whether that is still true. We read 85 years of temperature and rainfall records for twelve countries, measured how far they have moved, compared that with ordinary year-to-year swings, and then asked whether the unusual years were also unusual for the economy.</a:t>
             </a:r>
           </a:p>
         </p:txBody>
@@ -583,7 +591,13 @@
           <a:lstStyle/>
           <a:p>
             <a:r>
-              <a:t>Speaker 2 (9:30-10:00). Close, then hand over to the Q&amp;A team.</a:t>
+              <a:t>[Speaker 2 · 7:50-8:35]</a:t>
+            </a:r>
+          </a:p>
+          <a:p/>
+          <a:p>
+            <a:r>
+              <a:t>So where do climate shocks bite? In harvests rather than GDP, and through water rather than heat. On the right, a year ten percent wetter than normal goes with crop growth 2.2 points higher, and that estimate is precise. In dry years crop growth is 7.6 points below normal, while GDP growth is only 0.27 below. The likely reason is exposure: in most of our countries agriculture is one to three percent of GDP. This is the IPCC chain from the course: a hazard becomes a loss only through exposure and vulnerability.</a:t>
             </a:r>
           </a:p>
         </p:txBody>
@@ -653,7 +667,13 @@
           <a:lstStyle/>
           <a:p>
             <a:r>
-              <a:t>Use in Q&amp;A only.</a:t>
+              <a:t>[Speaker 2 · 8:35-9:30]</a:t>
+            </a:r>
+          </a:p>
+          <a:p/>
+          <a:p>
+            <a:r>
+              <a:t>Let us be precise about what kind of claims these are. The climate results are descriptions, and they are solid. The economic results are correlations. Year-to-year weather is close to random, so our design is close to an experiment, but twelve countries give intervals too wide to claim a causal effect on GDP. And a hot year is not climate change: one unusual year allows no adaptation and no build-up of damage. To go further we would need many more units, weather weighted by where crops and people are, and a channel chosen before looking at the data.</a:t>
             </a:r>
           </a:p>
         </p:txBody>
@@ -723,6 +743,164 @@
           <a:lstStyle/>
           <a:p>
             <a:r>
+              <a:t>[Speaker 2 · 9:30-10:00]</a:t>
+            </a:r>
+          </a:p>
+          <a:p/>
+          <a:p>
+            <a:r>
+              <a:t>To close: the warming in these records is unmistakable. Rainfall is a different, local story, and one that depends on how carefully you measure it. And when the climate misbehaves, the first place it shows is the harvest, not GDP. Thank you; we are happy to take questions.</a:t>
+            </a:r>
+          </a:p>
+        </p:txBody>
+      </p:sp>
+      <p:sp>
+        <p:nvSpPr>
+          <p:cNvPr id="4" name="Slide Number Placeholder 3"/>
+          <p:cNvSpPr>
+            <a:spLocks noGrp="1"/>
+          </p:cNvSpPr>
+          <p:nvPr>
+            <p:ph type="sldNum" idx="5" sz="quarter"/>
+          </p:nvPr>
+        </p:nvSpPr>
+        <p:spPr/>
+      </p:sp>
+    </p:spTree>
+  </p:cSld>
+  <p:clrMapOvr>
+    <a:masterClrMapping/>
+  </p:clrMapOvr>
+</p:notes>
+</file>
+
+<file path=ppt/notesSlides/notesSlide13.xml><?xml version="1.0" encoding="utf-8"?>
+<p:notes xmlns:a="http://schemas.openxmlformats.org/drawingml/2006/main" xmlns:p="http://schemas.openxmlformats.org/presentationml/2006/main" xmlns:r="http://schemas.openxmlformats.org/officeDocument/2006/relationships">
+  <p:cSld>
+    <p:spTree>
+      <p:nvGrpSpPr>
+        <p:cNvPr id="1" name=""/>
+        <p:cNvGrpSpPr/>
+        <p:nvPr/>
+      </p:nvGrpSpPr>
+      <p:grpSpPr>
+        <a:xfrm>
+          <a:off x="0" y="0"/>
+          <a:ext cx="0" cy="0"/>
+          <a:chOff x="0" y="0"/>
+          <a:chExt cx="0" cy="0"/>
+        </a:xfrm>
+      </p:grpSpPr>
+      <p:sp>
+        <p:nvSpPr>
+          <p:cNvPr id="2" name="Slide Image Placeholder 1"/>
+          <p:cNvSpPr>
+            <a:spLocks noGrp="1"/>
+          </p:cNvSpPr>
+          <p:nvPr>
+            <p:ph type="sldImg" idx="2"/>
+          </p:nvPr>
+        </p:nvSpPr>
+        <p:spPr/>
+      </p:sp>
+      <p:sp>
+        <p:nvSpPr>
+          <p:cNvPr id="3" name="Notes Placeholder 2"/>
+          <p:cNvSpPr>
+            <a:spLocks noGrp="1"/>
+          </p:cNvSpPr>
+          <p:nvPr>
+            <p:ph type="body" idx="3" sz="quarter"/>
+          </p:nvPr>
+        </p:nvSpPr>
+        <p:spPr/>
+        <p:txBody>
+          <a:bodyPr/>
+          <a:lstStyle/>
+          <a:p>
+            <a:r>
+              <a:t>[Backup · Q&amp;A]</a:t>
+            </a:r>
+          </a:p>
+          <a:p/>
+          <a:p>
+            <a:r>
+              <a:t>Use in Q&amp;A only.</a:t>
+            </a:r>
+          </a:p>
+        </p:txBody>
+      </p:sp>
+      <p:sp>
+        <p:nvSpPr>
+          <p:cNvPr id="4" name="Slide Number Placeholder 3"/>
+          <p:cNvSpPr>
+            <a:spLocks noGrp="1"/>
+          </p:cNvSpPr>
+          <p:nvPr>
+            <p:ph type="sldNum" idx="5" sz="quarter"/>
+          </p:nvPr>
+        </p:nvSpPr>
+        <p:spPr/>
+      </p:sp>
+    </p:spTree>
+  </p:cSld>
+  <p:clrMapOvr>
+    <a:masterClrMapping/>
+  </p:clrMapOvr>
+</p:notes>
+</file>
+
+<file path=ppt/notesSlides/notesSlide14.xml><?xml version="1.0" encoding="utf-8"?>
+<p:notes xmlns:a="http://schemas.openxmlformats.org/drawingml/2006/main" xmlns:p="http://schemas.openxmlformats.org/presentationml/2006/main" xmlns:r="http://schemas.openxmlformats.org/officeDocument/2006/relationships">
+  <p:cSld>
+    <p:spTree>
+      <p:nvGrpSpPr>
+        <p:cNvPr id="1" name=""/>
+        <p:cNvGrpSpPr/>
+        <p:nvPr/>
+      </p:nvGrpSpPr>
+      <p:grpSpPr>
+        <a:xfrm>
+          <a:off x="0" y="0"/>
+          <a:ext cx="0" cy="0"/>
+          <a:chOff x="0" y="0"/>
+          <a:chExt cx="0" cy="0"/>
+        </a:xfrm>
+      </p:grpSpPr>
+      <p:sp>
+        <p:nvSpPr>
+          <p:cNvPr id="2" name="Slide Image Placeholder 1"/>
+          <p:cNvSpPr>
+            <a:spLocks noGrp="1"/>
+          </p:cNvSpPr>
+          <p:nvPr>
+            <p:ph type="sldImg" idx="2"/>
+          </p:nvPr>
+        </p:nvSpPr>
+        <p:spPr/>
+      </p:sp>
+      <p:sp>
+        <p:nvSpPr>
+          <p:cNvPr id="3" name="Notes Placeholder 2"/>
+          <p:cNvSpPr>
+            <a:spLocks noGrp="1"/>
+          </p:cNvSpPr>
+          <p:nvPr>
+            <p:ph type="body" idx="3" sz="quarter"/>
+          </p:nvPr>
+        </p:nvSpPr>
+        <p:spPr/>
+        <p:txBody>
+          <a:bodyPr/>
+          <a:lstStyle/>
+          <a:p>
+            <a:r>
+              <a:t>[Backup · Q&amp;A]</a:t>
+            </a:r>
+          </a:p>
+          <a:p/>
+          <a:p>
+            <a:r>
               <a:t>Use in Q&amp;A only.</a:t>
             </a:r>
           </a:p>
@@ -793,7 +971,13 @@
           <a:lstStyle/>
           <a:p>
             <a:r>
-              <a:t>Speaker 1 (0:30-1:30). Three countries per continent so that we cover temperate, Mediterranean, tropical, monsoon and semi-arid climates. Point at the colours: warming since 1961-1990 ranges from +0.7 °C (Australia) to +1.8 °C (Germany). Data: Copernicus Interactive Climate Atlas, ERA5 reanalysis, averaged over each country; World Bank WDI for the economy.</a:t>
+              <a:t>[Speaker 1 · 0:35-1:15]</a:t>
+            </a:r>
+          </a:p>
+          <a:p/>
+          <a:p>
+            <a:r>
+              <a:t>Three countries per continent, chosen to cover temperate Europe, the Mediterranean, the Sahel, East Africa, the monsoon and the Americas, and economies where agriculture is anywhere from one to twenty-three percent of GDP. The headline is already on this map: every one of them is warmer than in 1961 to 1990, from +0.7 degrees in Australia and India to +1.85 in Germany. The rest of the talk asks whether that is large, when in the year it happens, and whether it matters. But first, a question we had to answer before anything else: what is the climate of a country?</a:t>
             </a:r>
           </a:p>
         </p:txBody>
@@ -863,7 +1047,13 @@
           <a:lstStyle/>
           <a:p>
             <a:r>
-              <a:t>Speaker 1 (1:30-2:45). Our first version used an API and one grid point at each capital. When we re-did it with the Atlas country averages the brief recommends, temperature barely changed, but rainfall did: Kenya, Mexico, the US change sign or size. Rainfall is local; a single 30 km cell is not a country. Lesson: check what the data measure before analysing them. Everything that follows uses country averages.</a:t>
+              <a:t>[Speaker 1 · 1:15-2:15]</a:t>
+            </a:r>
+          </a:p>
+          <a:p/>
+          <a:p>
+            <a:r>
+              <a:t>Our first version used a weather API and one grid point at each capital. When we rebuilt the data from the Copernicus Climate Atlas, which averages the ERA5 reanalysis over the whole country, temperature barely moved: the typical gap is 0.2 degrees. Rainfall did not survive: the typical gap is 9 percentage points, the United States goes from +32 percent at Washington to +4 for the country, and Kenya flips from +11 to -13. A warm year is warm over hundreds of kilometres; rain is local. So everything from now on is a country average. For France, Germany and Spain the Atlas has country masks; for the others we uploaded the borders into the Atlas's own user-defined region tool, and checked on France that both routes agree to four thousandths of a degree.</a:t>
             </a:r>
           </a:p>
         </p:txBody>
@@ -933,7 +1123,13 @@
           <a:lstStyle/>
           <a:p>
             <a:r>
-              <a:t>Speaker 1 (2:45-3:45). Each row is a country, each cell a year since 1940. We compute monthly anomalies against our own 1961-1990 baseline (the Atlas gives absolute values), which removes the seasonal cycle. Left: the last two decades are red everywhere. Right: rainfall alternates wet and dry without a clear drift. Pre-1950 data rest on fewer observations.</a:t>
+              <a:t>[Speaker 1 · 2:15-3:10]</a:t>
+            </a:r>
+          </a:p>
+          <a:p/>
+          <a:p>
+            <a:r>
+              <a:t>Here is the whole method on one country. On the left, raw monthly temperature: the seasons are 92% of the variation, so a January cannot be compared with a July. For each calendar month we subtract its average over our baseline, 1961 to 1990. The Atlas gives absolute values, so the baseline is our choice: the WMO reference period, before most of the warming. On the right, the annual result, with two numbers. The change, the last ten years against the baseline: +1.74 degrees. And the noise, sigma, how far an ordinary year strays from the trend: 0.51. Their ratio, 3.4, tells us whether the change could pass for a normal year. Above two, it could not.</a:t>
             </a:r>
           </a:p>
         </p:txBody>
@@ -1003,7 +1199,13 @@
           <a:lstStyle/>
           <a:p>
             <a:r>
-              <a:t>Speaker 1 (3:45-5:00). Our core description. Change of the last decade against the baseline, compared with how much an ordinary year deviates (σ). Temperature: beyond 2σ in 11 of 12 countries, i.e. the recent climate is outside what normal variability would produce. Rainfall: only 0 of 12. Temperature moves most in Europe and Mexico; rainfall moves in different places, and mostly not detectably.</a:t>
+              <a:t>[Speaker 1 · 3:10-3:50]</a:t>
+            </a:r>
+          </a:p>
+          <a:p/>
+          <a:p>
+            <a:r>
+              <a:t>Now all twelve countries, every year since 1940. On the left, temperature: blue before the 1980s, red after, and every country-year since 2016 is above its normal. On the right, rainfall, built the same way: it flickers between wet and dry, with no colour trend. The 1940s are faded because the reanalysis rests on fewer observations then, which is why we measure change from 1961. The next slide puts numbers on this contrast.</a:t>
             </a:r>
           </a:p>
         </p:txBody>
@@ -1073,7 +1275,13 @@
           <a:lstStyle/>
           <a:p>
             <a:r>
-              <a:t>Speaker 2 (5:00-6:00). Is the warming spread evenly across the year? Mostly yes within the noise. The boxed countries are those where the fastest season is significantly ahead, e.g. summer in France and Spain. Germany's winter warmed a lot but winters are so variable that the gap is not significant. Warning: Jun-Aug is winter in the southern hemisphere.</a:t>
+              <a:t>[Speaker 1 · 3:50-4:50]</a:t>
+            </a:r>
+          </a:p>
+          <a:p/>
+          <a:p>
+            <a:r>
+              <a:t>Each dot is the change; the grey bands are one and two sigmas of ordinary variation. Temperature is outside two sigma in 11 of 12 countries. Mexico is the clearest case: +1.4 degrees is 5.2 sigma, because its temperature barely varies from year to year. Germany warmed more, but its winters are so variable that it is 2.9 sigma. Australia is the exception, at 1.7. Rainfall: zero of twelve. Kenya and Senegal do show significant drying trends, but the last decade is still within a normal range. And rainfall does not change where warming is largest: the rank correlation across countries is 0.06.</a:t>
             </a:r>
           </a:p>
         </p:txBody>
@@ -1143,7 +1351,13 @@
           <a:lstStyle/>
           <a:p>
             <a:r>
-              <a:t>Speaker 2 (6:00-7:15). Now the economy. Hot-season temperature catches heatwaves that annual means dilute: France 2003 is a 3.5σ summer, but only 1.2σ as an annual mean. In the hottest summers, crop output often falls well below normal; GDP per capita barely moves, because agriculture is a few percent of GDP in most of our countries.</a:t>
+              <a:t>[Speaker 1 · 4:50-5:35]</a:t>
+            </a:r>
+          </a:p>
+          <a:p/>
+          <a:p>
+            <a:r>
+              <a:t>Is the warming spread evenly across the year? Mostly, yes. Only in France and Spain is one season clearly ahead: there, summer warmed by about +2.3 degrees against +1.3 in autumn. Germany's winter warmed even more, +2.5, but German winters vary so much that we cannot call it faster. Summer-heavy warming matters because it lands exactly when crops need water and cities need cooling, which brings us to the economy.</a:t>
             </a:r>
           </a:p>
         </p:txBody>
@@ -1213,7 +1427,13 @@
           <a:lstStyle/>
           <a:p>
             <a:r>
-              <a:t>Speaker 2 (7:15-8:30). Panel regression of growth on temperature and rainfall anomalies. Without year effects we would report -0.75 pp per °C, but warming and the post-1970 growth slowdown trend together. With country and year effects (preferred): -0.67 pp per °C, 95% CI [-1.49, +0.16], wild bootstrap p = 0.12. A typical warm year (1 SD) = -0.25 pp. 12 countries cannot tell this from zero.</a:t>
+              <a:t>[Speaker 2 · 5:35-6:35]</a:t>
+            </a:r>
+          </a:p>
+          <a:p/>
+          <a:p>
+            <a:r>
+              <a:t>So, the last part of the question: were the unusual climate years unusual for the economy? One measurement point first. An annual mean dilutes a heatwave: France's 2003 is only 1.2 sigma as a year, but 3.4 sigma as a summer. So we use each country's hot season, its three warmest months. Here is every country's hottest one on record, and how growth compared with what the country and the year would predict. Purple is crops, black is GDP. France 2003: crops -21 points, GDP -1.5. In 9 of 12 cases crops fell by more than five points; GDP fell in only 6. These are anecdotes, but they form a pattern, so let us test it.</a:t>
             </a:r>
           </a:p>
         </p:txBody>
@@ -1283,7 +1503,13 @@
           <a:lstStyle/>
           <a:p>
             <a:r>
-              <a:t>Speaker 2 (8:30-9:30). Be explicit about the type of each result: description, correlation, not causal. This is what the brief grades.</a:t>
+              <a:t>[Speaker 2 · 6:35-7:50]</a:t>
+            </a:r>
+          </a:p>
+          <a:p/>
+          <a:p>
+            <a:r>
+              <a:t>We regress growth on the temperature and rainfall anomalies over all 756 country-years. The grey lines are the naive versions. Comparing each country only with itself, a warmer year costs 0.75 points, and it looks significant. But that is partly timing: the world warmed while growth slowed after the 1960s. Year effects remove that, because they compare countries within the same year and absorb oil shocks, 2009 and COVID. That is our preferred model, in red: -0.67 points per degree, with an interval from -1.5 to +0.16. With only twelve countries we check it with a wild bootstrap: p = 0.12. Add country trends and it falls to -0.04. In words: a typical warm year might cost about 0.25 points of growth, and we cannot tell that apart from zero.</a:t>
             </a:r>
           </a:p>
         </p:txBody>
@@ -4291,14 +4517,57 @@
       <p:grpSpPr/>
       <p:sp>
         <p:nvSpPr>
-          <p:cNvPr id="2" name="TextBox 1"/>
+          <p:cNvPr id="2" name="Rectangle 1"/>
+          <p:cNvSpPr/>
+          <p:nvPr/>
+        </p:nvSpPr>
+        <p:spPr>
+          <a:xfrm>
+            <a:off x="0" y="0"/>
+            <a:ext cx="164592" cy="6858000"/>
+          </a:xfrm>
+          <a:prstGeom prst="rect">
+            <a:avLst/>
+          </a:prstGeom>
+          <a:solidFill>
+            <a:srgbClr val="C0392B"/>
+          </a:solidFill>
+          <a:ln>
+            <a:noFill/>
+          </a:ln>
+        </p:spPr>
+        <p:style>
+          <a:lnRef idx="1">
+            <a:schemeClr val="accent1"/>
+          </a:lnRef>
+          <a:fillRef idx="3">
+            <a:schemeClr val="accent1"/>
+          </a:fillRef>
+          <a:effectRef idx="2">
+            <a:schemeClr val="accent1"/>
+          </a:effectRef>
+          <a:fontRef idx="minor">
+            <a:schemeClr val="lt1"/>
+          </a:fontRef>
+        </p:style>
+        <p:txBody>
+          <a:bodyPr rtlCol="0" anchor="ctr"/>
+          <a:lstStyle/>
+          <a:p>
+            <a:pPr algn="ctr"/>
+          </a:p>
+        </p:txBody>
+      </p:sp>
+      <p:sp>
+        <p:nvSpPr>
+          <p:cNvPr id="3" name="TextBox 2"/>
           <p:cNvSpPr txBox="1"/>
           <p:nvPr/>
         </p:nvSpPr>
         <p:spPr>
           <a:xfrm>
-            <a:off x="548640" y="457200"/>
-            <a:ext cx="10972800" cy="1097280"/>
+            <a:off x="822960" y="1828800"/>
+            <a:ext cx="10515600" cy="1463040"/>
           </a:xfrm>
           <a:prstGeom prst="rect">
             <a:avLst/>
@@ -4312,22 +4581,26 @@
           <a:lstStyle/>
           <a:p>
             <a:r>
-              <a:rPr sz="3400" b="1"/>
-              <a:t>Temperature and precipitation records, 1940-2025</a:t>
-            </a:r>
-          </a:p>
-        </p:txBody>
-      </p:sp>
-      <p:sp>
-        <p:nvSpPr>
-          <p:cNvPr id="3" name="TextBox 2"/>
+              <a:rPr sz="4000" b="1">
+                <a:solidFill>
+                  <a:srgbClr val="1F2328"/>
+                </a:solidFill>
+              </a:rPr>
+              <a:t>Is today's climate still the one we planned for?</a:t>
+            </a:r>
+          </a:p>
+        </p:txBody>
+      </p:sp>
+      <p:sp>
+        <p:nvSpPr>
+          <p:cNvPr id="4" name="TextBox 3"/>
           <p:cNvSpPr txBox="1"/>
           <p:nvPr/>
         </p:nvSpPr>
         <p:spPr>
           <a:xfrm>
-            <a:off x="731520" y="1737360"/>
-            <a:ext cx="10789920" cy="4572000"/>
+            <a:off x="822960" y="3383280"/>
+            <a:ext cx="10515600" cy="914400"/>
           </a:xfrm>
           <a:prstGeom prst="rect">
             <a:avLst/>
@@ -4340,36 +4613,89 @@
           </a:bodyPr>
           <a:lstStyle/>
           <a:p>
-            <a:pPr>
-              <a:spcAft>
-                <a:spcPts val="1400"/>
-              </a:spcAft>
-              <a:defRPr sz="2200"/>
-            </a:pPr>
-            <a:r>
-              <a:t>What the observed records show for 12 countries, and whether the years that stand out in the climate also stand out in the economy</a:t>
-            </a:r>
-          </a:p>
-          <a:p>
-            <a:pPr>
-              <a:spcAft>
-                <a:spcPts val="1400"/>
-              </a:spcAft>
-              <a:defRPr sz="2200"/>
-            </a:pPr>
-            <a:r>
+            <a:r>
+              <a:rPr sz="2000" b="0">
+                <a:solidFill>
+                  <a:srgbClr val="6E7781"/>
+                </a:solidFill>
+              </a:rPr>
+              <a:t>Temperature and precipitation records for 12 countries, 1940-2025, and what they did to the economy</a:t>
+            </a:r>
+          </a:p>
+        </p:txBody>
+      </p:sp>
+      <p:sp>
+        <p:nvSpPr>
+          <p:cNvPr id="5" name="TextBox 4"/>
+          <p:cNvSpPr txBox="1"/>
+          <p:nvPr/>
+        </p:nvSpPr>
+        <p:spPr>
+          <a:xfrm>
+            <a:off x="822960" y="4937760"/>
+            <a:ext cx="10515600" cy="1097280"/>
+          </a:xfrm>
+          <a:prstGeom prst="rect">
+            <a:avLst/>
+          </a:prstGeom>
+          <a:noFill/>
+        </p:spPr>
+        <p:txBody>
+          <a:bodyPr wrap="square">
+            <a:spAutoFit/>
+          </a:bodyPr>
+          <a:lstStyle/>
+          <a:p>
+            <a:r>
+              <a:rPr sz="1600" b="0">
+                <a:solidFill>
+                  <a:srgbClr val="6E7781"/>
+                </a:solidFill>
+              </a:rPr>
               <a:t>Track 1 · Environmental Economics · ESSEC BSc AIDAMS · 9 November 2026</a:t>
             </a:r>
           </a:p>
           <a:p>
-            <a:pPr>
-              <a:spcAft>
-                <a:spcPts val="1400"/>
-              </a:spcAft>
-              <a:defRPr sz="2200"/>
-            </a:pPr>
-            <a:r>
+            <a:r>
+              <a:rPr sz="1600" b="0">
+                <a:solidFill>
+                  <a:srgbClr val="6E7781"/>
+                </a:solidFill>
+              </a:rPr>
               <a:t>[Group members]</a:t>
+            </a:r>
+          </a:p>
+        </p:txBody>
+      </p:sp>
+      <p:sp>
+        <p:nvSpPr>
+          <p:cNvPr id="6" name="TextBox 5"/>
+          <p:cNvSpPr txBox="1"/>
+          <p:nvPr/>
+        </p:nvSpPr>
+        <p:spPr>
+          <a:xfrm>
+            <a:off x="11430000" y="6446520"/>
+            <a:ext cx="640080" cy="365760"/>
+          </a:xfrm>
+          <a:prstGeom prst="rect">
+            <a:avLst/>
+          </a:prstGeom>
+          <a:noFill/>
+        </p:spPr>
+        <p:txBody>
+          <a:bodyPr wrap="square">
+            <a:spAutoFit/>
+          </a:bodyPr>
+          <a:lstStyle/>
+          <a:p>
+            <a:r>
+              <a:rPr sz="1100" b="0">
+                <a:solidFill>
+                  <a:srgbClr val="6E7781"/>
+                </a:solidFill>
+              </a:rPr>
+              <a:t>1</a:t>
             </a:r>
           </a:p>
         </p:txBody>
@@ -4392,16 +4718,40 @@
         <p:nvPr/>
       </p:nvGrpSpPr>
       <p:grpSpPr/>
-      <p:sp>
-        <p:nvSpPr>
-          <p:cNvPr id="2" name="TextBox 1"/>
+      <p:pic>
+        <p:nvPicPr>
+          <p:cNvPr id="2" name="Picture 1" descr="slide_10_crops_rain.png"/>
+          <p:cNvPicPr>
+            <a:picLocks noChangeAspect="1"/>
+          </p:cNvPicPr>
+          <p:nvPr/>
+        </p:nvPicPr>
+        <p:blipFill>
+          <a:blip r:embed="rId2"/>
+          <a:stretch>
+            <a:fillRect/>
+          </a:stretch>
+        </p:blipFill>
+        <p:spPr>
+          <a:xfrm>
+            <a:off x="556548" y="0"/>
+            <a:ext cx="11075855" cy="6858000"/>
+          </a:xfrm>
+          <a:prstGeom prst="rect">
+            <a:avLst/>
+          </a:prstGeom>
+        </p:spPr>
+      </p:pic>
+      <p:sp>
+        <p:nvSpPr>
+          <p:cNvPr id="3" name="TextBox 2"/>
           <p:cNvSpPr txBox="1"/>
           <p:nvPr/>
         </p:nvSpPr>
         <p:spPr>
           <a:xfrm>
-            <a:off x="548640" y="457200"/>
-            <a:ext cx="10972800" cy="1097280"/>
+            <a:off x="11430000" y="6446520"/>
+            <a:ext cx="640080" cy="365760"/>
           </a:xfrm>
           <a:prstGeom prst="rect">
             <a:avLst/>
@@ -4415,64 +4765,12 @@
           <a:lstStyle/>
           <a:p>
             <a:r>
-              <a:rPr sz="3400" b="1"/>
-              <a:t>Three takeaways</a:t>
-            </a:r>
-          </a:p>
-        </p:txBody>
-      </p:sp>
-      <p:sp>
-        <p:nvSpPr>
-          <p:cNvPr id="3" name="TextBox 2"/>
-          <p:cNvSpPr txBox="1"/>
-          <p:nvPr/>
-        </p:nvSpPr>
-        <p:spPr>
-          <a:xfrm>
-            <a:off x="731520" y="1737360"/>
-            <a:ext cx="10789920" cy="4572000"/>
-          </a:xfrm>
-          <a:prstGeom prst="rect">
-            <a:avLst/>
-          </a:prstGeom>
-          <a:noFill/>
-        </p:spPr>
-        <p:txBody>
-          <a:bodyPr wrap="square">
-            <a:spAutoFit/>
-          </a:bodyPr>
-          <a:lstStyle/>
-          <a:p>
-            <a:pPr>
-              <a:spcAft>
-                <a:spcPts val="1400"/>
-              </a:spcAft>
-              <a:defRPr sz="2600"/>
-            </a:pPr>
-            <a:r>
-              <a:t>1. Warming is unmistakable: +0.7 to +1.8 °C since 1961-1990, far outside normal variability.</a:t>
-            </a:r>
-          </a:p>
-          <a:p>
-            <a:pPr>
-              <a:spcAft>
-                <a:spcPts val="1400"/>
-              </a:spcAft>
-              <a:defRPr sz="2600"/>
-            </a:pPr>
-            <a:r>
-              <a:t>2. Rainfall is different: local, noisy, and sensitive to how you measure it.</a:t>
-            </a:r>
-          </a:p>
-          <a:p>
-            <a:pPr>
-              <a:spcAft>
-                <a:spcPts val="1400"/>
-              </a:spcAft>
-              <a:defRPr sz="2600"/>
-            </a:pPr>
-            <a:r>
-              <a:t>3. Climate shocks show up in crops before they show up in GDP.</a:t>
+              <a:rPr sz="1100" b="0">
+                <a:solidFill>
+                  <a:srgbClr val="6E7781"/>
+                </a:solidFill>
+              </a:rPr>
+              <a:t>10</a:t>
             </a:r>
           </a:p>
         </p:txBody>
@@ -4497,14 +4795,57 @@
       <p:grpSpPr/>
       <p:sp>
         <p:nvSpPr>
-          <p:cNvPr id="2" name="TextBox 1"/>
+          <p:cNvPr id="2" name="Rectangle 1"/>
+          <p:cNvSpPr/>
+          <p:nvPr/>
+        </p:nvSpPr>
+        <p:spPr>
+          <a:xfrm>
+            <a:off x="0" y="0"/>
+            <a:ext cx="164592" cy="6858000"/>
+          </a:xfrm>
+          <a:prstGeom prst="rect">
+            <a:avLst/>
+          </a:prstGeom>
+          <a:solidFill>
+            <a:srgbClr val="C0392B"/>
+          </a:solidFill>
+          <a:ln>
+            <a:noFill/>
+          </a:ln>
+        </p:spPr>
+        <p:style>
+          <a:lnRef idx="1">
+            <a:schemeClr val="accent1"/>
+          </a:lnRef>
+          <a:fillRef idx="3">
+            <a:schemeClr val="accent1"/>
+          </a:fillRef>
+          <a:effectRef idx="2">
+            <a:schemeClr val="accent1"/>
+          </a:effectRef>
+          <a:fontRef idx="minor">
+            <a:schemeClr val="lt1"/>
+          </a:fontRef>
+        </p:style>
+        <p:txBody>
+          <a:bodyPr rtlCol="0" anchor="ctr"/>
+          <a:lstStyle/>
+          <a:p>
+            <a:pPr algn="ctr"/>
+          </a:p>
+        </p:txBody>
+      </p:sp>
+      <p:sp>
+        <p:nvSpPr>
+          <p:cNvPr id="3" name="TextBox 2"/>
           <p:cNvSpPr txBox="1"/>
           <p:nvPr/>
         </p:nvSpPr>
         <p:spPr>
           <a:xfrm>
-            <a:off x="548640" y="457200"/>
-            <a:ext cx="10972800" cy="1097280"/>
+            <a:off x="640080" y="411480"/>
+            <a:ext cx="10972800" cy="914400"/>
           </a:xfrm>
           <a:prstGeom prst="rect">
             <a:avLst/>
@@ -4518,22 +4859,26 @@
           <a:lstStyle/>
           <a:p>
             <a:r>
-              <a:rPr sz="3400" b="1"/>
-              <a:t>Backup: data and definitions</a:t>
-            </a:r>
-          </a:p>
-        </p:txBody>
-      </p:sp>
-      <p:sp>
-        <p:nvSpPr>
-          <p:cNvPr id="3" name="TextBox 2"/>
+              <a:rPr sz="3400" b="1">
+                <a:solidFill>
+                  <a:srgbClr val="1F2328"/>
+                </a:solidFill>
+              </a:rPr>
+              <a:t>What we can and cannot conclude</a:t>
+            </a:r>
+          </a:p>
+        </p:txBody>
+      </p:sp>
+      <p:sp>
+        <p:nvSpPr>
+          <p:cNvPr id="4" name="TextBox 3"/>
           <p:cNvSpPr txBox="1"/>
           <p:nvPr/>
         </p:nvSpPr>
         <p:spPr>
           <a:xfrm>
-            <a:off x="731520" y="1737360"/>
-            <a:ext cx="10789920" cy="4572000"/>
+            <a:off x="822960" y="1554480"/>
+            <a:ext cx="10607040" cy="4846320"/>
           </a:xfrm>
           <a:prstGeom prst="rect">
             <a:avLst/>
@@ -4548,45 +4893,94 @@
           <a:p>
             <a:pPr>
               <a:spcAft>
-                <a:spcPts val="1400"/>
+                <a:spcPts val="1600"/>
               </a:spcAft>
-              <a:defRPr sz="1800"/>
+              <a:defRPr sz="1900">
+                <a:solidFill>
+                  <a:srgbClr val="1F2328"/>
+                </a:solidFill>
+              </a:defRPr>
             </a:pPr>
             <a:r>
-              <a:t>Climate: Copernicus Interactive Climate Atlas (C3S/ECMWF), ERA5, monthly 1940-2025. France, Germany, Spain: Atlas 'European countries' masks; 9 others: Atlas 'user-defined region' with Natural Earth borders (USA = 48 contiguous states).</a:t>
+              <a:t>▸  Description (solid): every country has warmed; 11/12 beyond normal variability; rainfall change within the noise.</a:t>
             </a:r>
           </a:p>
           <a:p>
             <a:pPr>
               <a:spcAft>
-                <a:spcPts val="1400"/>
+                <a:spcPts val="1600"/>
               </a:spcAft>
-              <a:defRPr sz="1800"/>
+              <a:defRPr sz="1900">
+                <a:solidFill>
+                  <a:srgbClr val="1F2328"/>
+                </a:solidFill>
+              </a:defRPr>
             </a:pPr>
             <a:r>
-              <a:t>Anomalies vs 1961-1990 per calendar month; precipitation = mm/day x days.</a:t>
+              <a:t>▸  Correlation: dry years go with lower harvests (clear); warm years with slightly lower GDP growth (not distinguishable from zero).</a:t>
             </a:r>
           </a:p>
           <a:p>
             <a:pPr>
               <a:spcAft>
-                <a:spcPts val="1400"/>
+                <a:spcPts val="1600"/>
               </a:spcAft>
-              <a:defRPr sz="1800"/>
+              <a:defRPr sz="1900">
+                <a:solidFill>
+                  <a:srgbClr val="1F2328"/>
+                </a:solidFill>
+              </a:defRPr>
             </a:pPr>
             <a:r>
-              <a:t>Economy: World Bank WDI, release 8 Oct 2026: GDP per capita growth, crop production index, agriculture share.</a:t>
+              <a:t>▸  Not causal, and not climate change: one unusual year allows no adaptation; 12 countries are too few; national averages hide local losses.</a:t>
             </a:r>
           </a:p>
           <a:p>
             <a:pPr>
               <a:spcAft>
-                <a:spcPts val="1400"/>
+                <a:spcPts val="1600"/>
               </a:spcAft>
-              <a:defRPr sz="1800"/>
+              <a:defRPr sz="1900">
+                <a:solidFill>
+                  <a:srgbClr val="1F2328"/>
+                </a:solidFill>
+              </a:defRPr>
             </a:pPr>
             <a:r>
-              <a:t>Regressions: two-way fixed effects, SE clustered by country (t(11)) + wild cluster bootstrap.</a:t>
+              <a:t>▸  To make it causal: many more units (all countries, regions), exposure-weighted weather, a channel fixed in advance.</a:t>
+            </a:r>
+          </a:p>
+        </p:txBody>
+      </p:sp>
+      <p:sp>
+        <p:nvSpPr>
+          <p:cNvPr id="5" name="TextBox 4"/>
+          <p:cNvSpPr txBox="1"/>
+          <p:nvPr/>
+        </p:nvSpPr>
+        <p:spPr>
+          <a:xfrm>
+            <a:off x="11430000" y="6446520"/>
+            <a:ext cx="640080" cy="365760"/>
+          </a:xfrm>
+          <a:prstGeom prst="rect">
+            <a:avLst/>
+          </a:prstGeom>
+          <a:noFill/>
+        </p:spPr>
+        <p:txBody>
+          <a:bodyPr wrap="square">
+            <a:spAutoFit/>
+          </a:bodyPr>
+          <a:lstStyle/>
+          <a:p>
+            <a:r>
+              <a:rPr sz="1100" b="0">
+                <a:solidFill>
+                  <a:srgbClr val="6E7781"/>
+                </a:solidFill>
+              </a:rPr>
+              <a:t>11</a:t>
             </a:r>
           </a:p>
         </p:txBody>
@@ -4611,14 +5005,57 @@
       <p:grpSpPr/>
       <p:sp>
         <p:nvSpPr>
-          <p:cNvPr id="2" name="TextBox 1"/>
+          <p:cNvPr id="2" name="Rectangle 1"/>
+          <p:cNvSpPr/>
+          <p:nvPr/>
+        </p:nvSpPr>
+        <p:spPr>
+          <a:xfrm>
+            <a:off x="0" y="0"/>
+            <a:ext cx="164592" cy="6858000"/>
+          </a:xfrm>
+          <a:prstGeom prst="rect">
+            <a:avLst/>
+          </a:prstGeom>
+          <a:solidFill>
+            <a:srgbClr val="C0392B"/>
+          </a:solidFill>
+          <a:ln>
+            <a:noFill/>
+          </a:ln>
+        </p:spPr>
+        <p:style>
+          <a:lnRef idx="1">
+            <a:schemeClr val="accent1"/>
+          </a:lnRef>
+          <a:fillRef idx="3">
+            <a:schemeClr val="accent1"/>
+          </a:fillRef>
+          <a:effectRef idx="2">
+            <a:schemeClr val="accent1"/>
+          </a:effectRef>
+          <a:fontRef idx="minor">
+            <a:schemeClr val="lt1"/>
+          </a:fontRef>
+        </p:style>
+        <p:txBody>
+          <a:bodyPr rtlCol="0" anchor="ctr"/>
+          <a:lstStyle/>
+          <a:p>
+            <a:pPr algn="ctr"/>
+          </a:p>
+        </p:txBody>
+      </p:sp>
+      <p:sp>
+        <p:nvSpPr>
+          <p:cNvPr id="3" name="TextBox 2"/>
           <p:cNvSpPr txBox="1"/>
           <p:nvPr/>
         </p:nvSpPr>
         <p:spPr>
           <a:xfrm>
-            <a:off x="548640" y="457200"/>
-            <a:ext cx="10972800" cy="1097280"/>
+            <a:off x="640080" y="411480"/>
+            <a:ext cx="10972800" cy="914400"/>
           </a:xfrm>
           <a:prstGeom prst="rect">
             <a:avLst/>
@@ -4632,22 +5069,26 @@
           <a:lstStyle/>
           <a:p>
             <a:r>
-              <a:rPr sz="3400" b="1"/>
-              <a:t>Backup: likely questions</a:t>
-            </a:r>
-          </a:p>
-        </p:txBody>
-      </p:sp>
-      <p:sp>
-        <p:nvSpPr>
-          <p:cNvPr id="3" name="TextBox 2"/>
+              <a:rPr sz="3400" b="1">
+                <a:solidFill>
+                  <a:srgbClr val="1F2328"/>
+                </a:solidFill>
+              </a:rPr>
+              <a:t>Three takeaways</a:t>
+            </a:r>
+          </a:p>
+        </p:txBody>
+      </p:sp>
+      <p:sp>
+        <p:nvSpPr>
+          <p:cNvPr id="4" name="TextBox 3"/>
           <p:cNvSpPr txBox="1"/>
           <p:nvPr/>
         </p:nvSpPr>
         <p:spPr>
           <a:xfrm>
-            <a:off x="731520" y="1737360"/>
-            <a:ext cx="10789920" cy="4572000"/>
+            <a:off x="822960" y="1554480"/>
+            <a:ext cx="10607040" cy="4846320"/>
           </a:xfrm>
           <a:prstGeom prst="rect">
             <a:avLst/>
@@ -4662,45 +5103,448 @@
           <a:p>
             <a:pPr>
               <a:spcAft>
-                <a:spcPts val="1400"/>
+                <a:spcPts val="1600"/>
               </a:spcAft>
-              <a:defRPr sz="1800"/>
+              <a:defRPr sz="2200">
+                <a:solidFill>
+                  <a:srgbClr val="1F2328"/>
+                </a:solidFill>
+              </a:defRPr>
             </a:pPr>
             <a:r>
-              <a:t>Why not the capital-city API? Rainfall at one point is not the country's rainfall (slide 3).</a:t>
+              <a:t>▸  Warming is unmistakable: +0.7 to +1.85 °C since 1961-1990, far outside normal variability.</a:t>
             </a:r>
           </a:p>
           <a:p>
             <a:pPr>
               <a:spcAft>
-                <a:spcPts val="1400"/>
+                <a:spcPts val="1600"/>
               </a:spcAft>
-              <a:defRPr sz="1800"/>
+              <a:defRPr sz="2200">
+                <a:solidFill>
+                  <a:srgbClr val="1F2328"/>
+                </a:solidFill>
+              </a:defRPr>
             </a:pPr>
             <a:r>
-              <a:t>Why does Country FE give a big effect? Warming and the growth slowdown both trend over time.</a:t>
+              <a:t>▸  Rainfall is local and noisy, and it depends on how you measure it.</a:t>
             </a:r>
           </a:p>
           <a:p>
             <a:pPr>
               <a:spcAft>
-                <a:spcPts val="1400"/>
+                <a:spcPts val="1600"/>
               </a:spcAft>
-              <a:defRPr sz="1800"/>
+              <a:defRPr sz="2200">
+                <a:solidFill>
+                  <a:srgbClr val="1F2328"/>
+                </a:solidFill>
+              </a:defRPr>
             </a:pPr>
             <a:r>
-              <a:t>Is p ≈ 0.5 'no effect'? No: the CI is wide; we cannot rule out a sizeable effect.</a:t>
-            </a:r>
-          </a:p>
+              <a:t>▸  Climate shocks reach harvests long before they reach GDP.</a:t>
+            </a:r>
+          </a:p>
+        </p:txBody>
+      </p:sp>
+      <p:sp>
+        <p:nvSpPr>
+          <p:cNvPr id="5" name="TextBox 4"/>
+          <p:cNvSpPr txBox="1"/>
+          <p:nvPr/>
+        </p:nvSpPr>
+        <p:spPr>
+          <a:xfrm>
+            <a:off x="11430000" y="6446520"/>
+            <a:ext cx="640080" cy="365760"/>
+          </a:xfrm>
+          <a:prstGeom prst="rect">
+            <a:avLst/>
+          </a:prstGeom>
+          <a:noFill/>
+        </p:spPr>
+        <p:txBody>
+          <a:bodyPr wrap="square">
+            <a:spAutoFit/>
+          </a:bodyPr>
+          <a:lstStyle/>
+          <a:p>
+            <a:r>
+              <a:rPr sz="1100" b="0">
+                <a:solidFill>
+                  <a:srgbClr val="6E7781"/>
+                </a:solidFill>
+              </a:rPr>
+              <a:t>12</a:t>
+            </a:r>
+          </a:p>
+        </p:txBody>
+      </p:sp>
+    </p:spTree>
+  </p:cSld>
+  <p:clrMapOvr>
+    <a:masterClrMapping/>
+  </p:clrMapOvr>
+</p:sld>
+</file>
+
+<file path=ppt/slides/slide13.xml><?xml version="1.0" encoding="utf-8"?>
+<p:sld xmlns:a="http://schemas.openxmlformats.org/drawingml/2006/main" xmlns:p="http://schemas.openxmlformats.org/presentationml/2006/main" xmlns:r="http://schemas.openxmlformats.org/officeDocument/2006/relationships">
+  <p:cSld>
+    <p:spTree>
+      <p:nvGrpSpPr>
+        <p:cNvPr id="1" name=""/>
+        <p:cNvGrpSpPr/>
+        <p:nvPr/>
+      </p:nvGrpSpPr>
+      <p:grpSpPr/>
+      <p:sp>
+        <p:nvSpPr>
+          <p:cNvPr id="2" name="Rectangle 1"/>
+          <p:cNvSpPr/>
+          <p:nvPr/>
+        </p:nvSpPr>
+        <p:spPr>
+          <a:xfrm>
+            <a:off x="0" y="0"/>
+            <a:ext cx="164592" cy="6858000"/>
+          </a:xfrm>
+          <a:prstGeom prst="rect">
+            <a:avLst/>
+          </a:prstGeom>
+          <a:solidFill>
+            <a:srgbClr val="C0392B"/>
+          </a:solidFill>
+          <a:ln>
+            <a:noFill/>
+          </a:ln>
+        </p:spPr>
+        <p:style>
+          <a:lnRef idx="1">
+            <a:schemeClr val="accent1"/>
+          </a:lnRef>
+          <a:fillRef idx="3">
+            <a:schemeClr val="accent1"/>
+          </a:fillRef>
+          <a:effectRef idx="2">
+            <a:schemeClr val="accent1"/>
+          </a:effectRef>
+          <a:fontRef idx="minor">
+            <a:schemeClr val="lt1"/>
+          </a:fontRef>
+        </p:style>
+        <p:txBody>
+          <a:bodyPr rtlCol="0" anchor="ctr"/>
+          <a:lstStyle/>
+          <a:p>
+            <a:pPr algn="ctr"/>
+          </a:p>
+        </p:txBody>
+      </p:sp>
+      <p:sp>
+        <p:nvSpPr>
+          <p:cNvPr id="3" name="TextBox 2"/>
+          <p:cNvSpPr txBox="1"/>
+          <p:nvPr/>
+        </p:nvSpPr>
+        <p:spPr>
+          <a:xfrm>
+            <a:off x="640080" y="411480"/>
+            <a:ext cx="10972800" cy="914400"/>
+          </a:xfrm>
+          <a:prstGeom prst="rect">
+            <a:avLst/>
+          </a:prstGeom>
+          <a:noFill/>
+        </p:spPr>
+        <p:txBody>
+          <a:bodyPr wrap="square">
+            <a:spAutoFit/>
+          </a:bodyPr>
+          <a:lstStyle/>
+          <a:p>
+            <a:r>
+              <a:rPr sz="3400" b="1">
+                <a:solidFill>
+                  <a:srgbClr val="1F2328"/>
+                </a:solidFill>
+              </a:rPr>
+              <a:t>Backup: data and definitions</a:t>
+            </a:r>
+          </a:p>
+        </p:txBody>
+      </p:sp>
+      <p:sp>
+        <p:nvSpPr>
+          <p:cNvPr id="4" name="TextBox 3"/>
+          <p:cNvSpPr txBox="1"/>
+          <p:nvPr/>
+        </p:nvSpPr>
+        <p:spPr>
+          <a:xfrm>
+            <a:off x="822960" y="1554480"/>
+            <a:ext cx="10607040" cy="4846320"/>
+          </a:xfrm>
+          <a:prstGeom prst="rect">
+            <a:avLst/>
+          </a:prstGeom>
+          <a:noFill/>
+        </p:spPr>
+        <p:txBody>
+          <a:bodyPr wrap="square">
+            <a:spAutoFit/>
+          </a:bodyPr>
+          <a:lstStyle/>
           <a:p>
             <a:pPr>
               <a:spcAft>
-                <a:spcPts val="1400"/>
+                <a:spcPts val="1600"/>
               </a:spcAft>
-              <a:defRPr sz="1800"/>
+              <a:defRPr sz="1600">
+                <a:solidFill>
+                  <a:srgbClr val="1F2328"/>
+                </a:solidFill>
+              </a:defRPr>
             </a:pPr>
             <a:r>
-              <a:t>Why hot season? An annual mean dilutes a 2-month heatwave (France 2003: 3.5σ summer, 1.2σ year).</a:t>
+              <a:t>▸  Climate: Copernicus Interactive Climate Atlas (C3S/ECMWF), ERA5, monthly 1940-2025, 288 series. FRA/DEU/ESP: Atlas country masks; 9 others: Atlas user-defined regions with Natural Earth borders (USA = 48 states). Validated on France to 0.004 °C.</a:t>
+            </a:r>
+          </a:p>
+          <a:p>
+            <a:pPr>
+              <a:spcAft>
+                <a:spcPts val="1600"/>
+              </a:spcAft>
+              <a:defRPr sz="1600">
+                <a:solidFill>
+                  <a:srgbClr val="1F2328"/>
+                </a:solidFill>
+              </a:defRPr>
+            </a:pPr>
+            <a:r>
+              <a:t>▸  Anomaly = month minus its 1961-1990 calendar-month mean; precipitation = mm/day × days; Δ = mean 2016-2025; σ = SD of the detrended annual anomaly.</a:t>
+            </a:r>
+          </a:p>
+          <a:p>
+            <a:pPr>
+              <a:spcAft>
+                <a:spcPts val="1600"/>
+              </a:spcAft>
+              <a:defRPr sz="1600">
+                <a:solidFill>
+                  <a:srgbClr val="1F2328"/>
+                </a:solidFill>
+              </a:defRPr>
+            </a:pPr>
+            <a:r>
+              <a:t>▸  Economy: World Bank WDI, release 8 Oct 2026: GDP per capita growth, crop production index, agriculture share.</a:t>
+            </a:r>
+          </a:p>
+          <a:p>
+            <a:pPr>
+              <a:spcAft>
+                <a:spcPts val="1600"/>
+              </a:spcAft>
+              <a:defRPr sz="1600">
+                <a:solidFill>
+                  <a:srgbClr val="1F2328"/>
+                </a:solidFill>
+              </a:defRPr>
+            </a:pPr>
+            <a:r>
+              <a:t>▸  Regressions: two-way fixed effects, SE clustered by country, t(11) + wild cluster bootstrap (Webb weights, 9,999 draws).</a:t>
+            </a:r>
+          </a:p>
+        </p:txBody>
+      </p:sp>
+    </p:spTree>
+  </p:cSld>
+  <p:clrMapOvr>
+    <a:masterClrMapping/>
+  </p:clrMapOvr>
+</p:sld>
+</file>
+
+<file path=ppt/slides/slide14.xml><?xml version="1.0" encoding="utf-8"?>
+<p:sld xmlns:a="http://schemas.openxmlformats.org/drawingml/2006/main" xmlns:p="http://schemas.openxmlformats.org/presentationml/2006/main" xmlns:r="http://schemas.openxmlformats.org/officeDocument/2006/relationships">
+  <p:cSld>
+    <p:spTree>
+      <p:nvGrpSpPr>
+        <p:cNvPr id="1" name=""/>
+        <p:cNvGrpSpPr/>
+        <p:nvPr/>
+      </p:nvGrpSpPr>
+      <p:grpSpPr/>
+      <p:sp>
+        <p:nvSpPr>
+          <p:cNvPr id="2" name="Rectangle 1"/>
+          <p:cNvSpPr/>
+          <p:nvPr/>
+        </p:nvSpPr>
+        <p:spPr>
+          <a:xfrm>
+            <a:off x="0" y="0"/>
+            <a:ext cx="164592" cy="6858000"/>
+          </a:xfrm>
+          <a:prstGeom prst="rect">
+            <a:avLst/>
+          </a:prstGeom>
+          <a:solidFill>
+            <a:srgbClr val="C0392B"/>
+          </a:solidFill>
+          <a:ln>
+            <a:noFill/>
+          </a:ln>
+        </p:spPr>
+        <p:style>
+          <a:lnRef idx="1">
+            <a:schemeClr val="accent1"/>
+          </a:lnRef>
+          <a:fillRef idx="3">
+            <a:schemeClr val="accent1"/>
+          </a:fillRef>
+          <a:effectRef idx="2">
+            <a:schemeClr val="accent1"/>
+          </a:effectRef>
+          <a:fontRef idx="minor">
+            <a:schemeClr val="lt1"/>
+          </a:fontRef>
+        </p:style>
+        <p:txBody>
+          <a:bodyPr rtlCol="0" anchor="ctr"/>
+          <a:lstStyle/>
+          <a:p>
+            <a:pPr algn="ctr"/>
+          </a:p>
+        </p:txBody>
+      </p:sp>
+      <p:sp>
+        <p:nvSpPr>
+          <p:cNvPr id="3" name="TextBox 2"/>
+          <p:cNvSpPr txBox="1"/>
+          <p:nvPr/>
+        </p:nvSpPr>
+        <p:spPr>
+          <a:xfrm>
+            <a:off x="640080" y="411480"/>
+            <a:ext cx="10972800" cy="914400"/>
+          </a:xfrm>
+          <a:prstGeom prst="rect">
+            <a:avLst/>
+          </a:prstGeom>
+          <a:noFill/>
+        </p:spPr>
+        <p:txBody>
+          <a:bodyPr wrap="square">
+            <a:spAutoFit/>
+          </a:bodyPr>
+          <a:lstStyle/>
+          <a:p>
+            <a:r>
+              <a:rPr sz="3400" b="1">
+                <a:solidFill>
+                  <a:srgbClr val="1F2328"/>
+                </a:solidFill>
+              </a:rPr>
+              <a:t>Backup: likely questions</a:t>
+            </a:r>
+          </a:p>
+        </p:txBody>
+      </p:sp>
+      <p:sp>
+        <p:nvSpPr>
+          <p:cNvPr id="4" name="TextBox 3"/>
+          <p:cNvSpPr txBox="1"/>
+          <p:nvPr/>
+        </p:nvSpPr>
+        <p:spPr>
+          <a:xfrm>
+            <a:off x="822960" y="1554480"/>
+            <a:ext cx="10607040" cy="4846320"/>
+          </a:xfrm>
+          <a:prstGeom prst="rect">
+            <a:avLst/>
+          </a:prstGeom>
+          <a:noFill/>
+        </p:spPr>
+        <p:txBody>
+          <a:bodyPr wrap="square">
+            <a:spAutoFit/>
+          </a:bodyPr>
+          <a:lstStyle/>
+          <a:p>
+            <a:pPr>
+              <a:spcAft>
+                <a:spcPts val="1600"/>
+              </a:spcAft>
+              <a:defRPr sz="1600">
+                <a:solidFill>
+                  <a:srgbClr val="1F2328"/>
+                </a:solidFill>
+              </a:defRPr>
+            </a:pPr>
+            <a:r>
+              <a:t>▸  Why not the API? One grid point is not a country, above all for rainfall.</a:t>
+            </a:r>
+          </a:p>
+          <a:p>
+            <a:pPr>
+              <a:spcAft>
+                <a:spcPts val="1600"/>
+              </a:spcAft>
+              <a:defRPr sz="1600">
+                <a:solidFill>
+                  <a:srgbClr val="1F2328"/>
+                </a:solidFill>
+              </a:defRPr>
+            </a:pPr>
+            <a:r>
+              <a:t>▸  Why does the naive model give a big effect? Warming and the growth slowdown both trend over time.</a:t>
+            </a:r>
+          </a:p>
+          <a:p>
+            <a:pPr>
+              <a:spcAft>
+                <a:spcPts val="1600"/>
+              </a:spcAft>
+              <a:defRPr sz="1600">
+                <a:solidFill>
+                  <a:srgbClr val="1F2328"/>
+                </a:solidFill>
+              </a:defRPr>
+            </a:pPr>
+            <a:r>
+              <a:t>▸  Is p ≈ 0.1 'no effect'? No: the interval also includes a loss of 1.5 pp per °C.</a:t>
+            </a:r>
+          </a:p>
+          <a:p>
+            <a:pPr>
+              <a:spcAft>
+                <a:spcPts val="1600"/>
+              </a:spcAft>
+              <a:defRPr sz="1600">
+                <a:solidFill>
+                  <a:srgbClr val="1F2328"/>
+                </a:solidFill>
+              </a:defRPr>
+            </a:pPr>
+            <a:r>
+              <a:t>▸  Why the hot season? France 2003: 1.2σ as a year, 3.4σ as a summer.</a:t>
+            </a:r>
+          </a:p>
+          <a:p>
+            <a:pPr>
+              <a:spcAft>
+                <a:spcPts val="1600"/>
+              </a:spcAft>
+              <a:defRPr sz="1600">
+                <a:solidFill>
+                  <a:srgbClr val="1F2328"/>
+                </a:solidFill>
+              </a:defRPr>
+            </a:pPr>
+            <a:r>
+              <a:t>▸  Why 1961-1990? WMO reference, before most of the warming, and the start of the WDI data.</a:t>
             </a:r>
           </a:p>
         </p:txBody>
@@ -4725,7 +5569,7 @@
       <p:grpSpPr/>
       <p:pic>
         <p:nvPicPr>
-          <p:cNvPr id="2" name="Picture 1" descr="slide_01_map.png"/>
+          <p:cNvPr id="2" name="Picture 1" descr="slide_02_map.png"/>
           <p:cNvPicPr>
             <a:picLocks noChangeAspect="1"/>
           </p:cNvPicPr>
@@ -4747,6 +5591,39 @@
           </a:prstGeom>
         </p:spPr>
       </p:pic>
+      <p:sp>
+        <p:nvSpPr>
+          <p:cNvPr id="3" name="TextBox 2"/>
+          <p:cNvSpPr txBox="1"/>
+          <p:nvPr/>
+        </p:nvSpPr>
+        <p:spPr>
+          <a:xfrm>
+            <a:off x="11430000" y="6446520"/>
+            <a:ext cx="640080" cy="365760"/>
+          </a:xfrm>
+          <a:prstGeom prst="rect">
+            <a:avLst/>
+          </a:prstGeom>
+          <a:noFill/>
+        </p:spPr>
+        <p:txBody>
+          <a:bodyPr wrap="square">
+            <a:spAutoFit/>
+          </a:bodyPr>
+          <a:lstStyle/>
+          <a:p>
+            <a:r>
+              <a:rPr sz="1100" b="0">
+                <a:solidFill>
+                  <a:srgbClr val="6E7781"/>
+                </a:solidFill>
+              </a:rPr>
+              <a:t>2</a:t>
+            </a:r>
+          </a:p>
+        </p:txBody>
+      </p:sp>
     </p:spTree>
   </p:cSld>
   <p:clrMapOvr>
@@ -4767,7 +5644,7 @@
       <p:grpSpPr/>
       <p:pic>
         <p:nvPicPr>
-          <p:cNvPr id="2" name="Picture 1" descr="slide_02_data_route.png"/>
+          <p:cNvPr id="2" name="Picture 1" descr="slide_03_data_route.png"/>
           <p:cNvPicPr>
             <a:picLocks noChangeAspect="1"/>
           </p:cNvPicPr>
@@ -4789,6 +5666,39 @@
           </a:prstGeom>
         </p:spPr>
       </p:pic>
+      <p:sp>
+        <p:nvSpPr>
+          <p:cNvPr id="3" name="TextBox 2"/>
+          <p:cNvSpPr txBox="1"/>
+          <p:nvPr/>
+        </p:nvSpPr>
+        <p:spPr>
+          <a:xfrm>
+            <a:off x="11430000" y="6446520"/>
+            <a:ext cx="640080" cy="365760"/>
+          </a:xfrm>
+          <a:prstGeom prst="rect">
+            <a:avLst/>
+          </a:prstGeom>
+          <a:noFill/>
+        </p:spPr>
+        <p:txBody>
+          <a:bodyPr wrap="square">
+            <a:spAutoFit/>
+          </a:bodyPr>
+          <a:lstStyle/>
+          <a:p>
+            <a:r>
+              <a:rPr sz="1100" b="0">
+                <a:solidFill>
+                  <a:srgbClr val="6E7781"/>
+                </a:solidFill>
+              </a:rPr>
+              <a:t>3</a:t>
+            </a:r>
+          </a:p>
+        </p:txBody>
+      </p:sp>
     </p:spTree>
   </p:cSld>
   <p:clrMapOvr>
@@ -4809,7 +5719,82 @@
       <p:grpSpPr/>
       <p:pic>
         <p:nvPicPr>
-          <p:cNvPr id="2" name="Picture 1" descr="slide_03_stripes.png"/>
+          <p:cNvPr id="2" name="Picture 1" descr="slide_04_method.png"/>
+          <p:cNvPicPr>
+            <a:picLocks noChangeAspect="1"/>
+          </p:cNvPicPr>
+          <p:nvPr/>
+        </p:nvPicPr>
+        <p:blipFill>
+          <a:blip r:embed="rId2"/>
+          <a:stretch>
+            <a:fillRect/>
+          </a:stretch>
+        </p:blipFill>
+        <p:spPr>
+          <a:xfrm>
+            <a:off x="0" y="9631"/>
+            <a:ext cx="12188952" cy="6838738"/>
+          </a:xfrm>
+          <a:prstGeom prst="rect">
+            <a:avLst/>
+          </a:prstGeom>
+        </p:spPr>
+      </p:pic>
+      <p:sp>
+        <p:nvSpPr>
+          <p:cNvPr id="3" name="TextBox 2"/>
+          <p:cNvSpPr txBox="1"/>
+          <p:nvPr/>
+        </p:nvSpPr>
+        <p:spPr>
+          <a:xfrm>
+            <a:off x="11430000" y="6446520"/>
+            <a:ext cx="640080" cy="365760"/>
+          </a:xfrm>
+          <a:prstGeom prst="rect">
+            <a:avLst/>
+          </a:prstGeom>
+          <a:noFill/>
+        </p:spPr>
+        <p:txBody>
+          <a:bodyPr wrap="square">
+            <a:spAutoFit/>
+          </a:bodyPr>
+          <a:lstStyle/>
+          <a:p>
+            <a:r>
+              <a:rPr sz="1100" b="0">
+                <a:solidFill>
+                  <a:srgbClr val="6E7781"/>
+                </a:solidFill>
+              </a:rPr>
+              <a:t>4</a:t>
+            </a:r>
+          </a:p>
+        </p:txBody>
+      </p:sp>
+    </p:spTree>
+  </p:cSld>
+  <p:clrMapOvr>
+    <a:masterClrMapping/>
+  </p:clrMapOvr>
+</p:sld>
+</file>
+
+<file path=ppt/slides/slide5.xml><?xml version="1.0" encoding="utf-8"?>
+<p:sld xmlns:a="http://schemas.openxmlformats.org/drawingml/2006/main" xmlns:p="http://schemas.openxmlformats.org/presentationml/2006/main" xmlns:r="http://schemas.openxmlformats.org/officeDocument/2006/relationships">
+  <p:cSld>
+    <p:spTree>
+      <p:nvGrpSpPr>
+        <p:cNvPr id="1" name=""/>
+        <p:cNvGrpSpPr/>
+        <p:nvPr/>
+      </p:nvGrpSpPr>
+      <p:grpSpPr/>
+      <p:pic>
+        <p:nvPicPr>
+          <p:cNvPr id="2" name="Picture 1" descr="slide_05_stripes.png"/>
           <p:cNvPicPr>
             <a:picLocks noChangeAspect="1"/>
           </p:cNvPicPr>
@@ -4831,6 +5816,39 @@
           </a:prstGeom>
         </p:spPr>
       </p:pic>
+      <p:sp>
+        <p:nvSpPr>
+          <p:cNvPr id="3" name="TextBox 2"/>
+          <p:cNvSpPr txBox="1"/>
+          <p:nvPr/>
+        </p:nvSpPr>
+        <p:spPr>
+          <a:xfrm>
+            <a:off x="11430000" y="6446520"/>
+            <a:ext cx="640080" cy="365760"/>
+          </a:xfrm>
+          <a:prstGeom prst="rect">
+            <a:avLst/>
+          </a:prstGeom>
+          <a:noFill/>
+        </p:spPr>
+        <p:txBody>
+          <a:bodyPr wrap="square">
+            <a:spAutoFit/>
+          </a:bodyPr>
+          <a:lstStyle/>
+          <a:p>
+            <a:r>
+              <a:rPr sz="1100" b="0">
+                <a:solidFill>
+                  <a:srgbClr val="6E7781"/>
+                </a:solidFill>
+              </a:rPr>
+              <a:t>5</a:t>
+            </a:r>
+          </a:p>
+        </p:txBody>
+      </p:sp>
     </p:spTree>
   </p:cSld>
   <p:clrMapOvr>
@@ -4839,7 +5857,7 @@
 </p:sld>
 </file>
 
-<file path=ppt/slides/slide5.xml><?xml version="1.0" encoding="utf-8"?>
+<file path=ppt/slides/slide6.xml><?xml version="1.0" encoding="utf-8"?>
 <p:sld xmlns:a="http://schemas.openxmlformats.org/drawingml/2006/main" xmlns:p="http://schemas.openxmlformats.org/presentationml/2006/main" xmlns:r="http://schemas.openxmlformats.org/officeDocument/2006/relationships">
   <p:cSld>
     <p:spTree>
@@ -4851,7 +5869,7 @@
       <p:grpSpPr/>
       <p:pic>
         <p:nvPicPr>
-          <p:cNvPr id="2" name="Picture 1" descr="slide_04_signal_noise.png"/>
+          <p:cNvPr id="2" name="Picture 1" descr="slide_06_signal_noise.png"/>
           <p:cNvPicPr>
             <a:picLocks noChangeAspect="1"/>
           </p:cNvPicPr>
@@ -4873,6 +5891,39 @@
           </a:prstGeom>
         </p:spPr>
       </p:pic>
+      <p:sp>
+        <p:nvSpPr>
+          <p:cNvPr id="3" name="TextBox 2"/>
+          <p:cNvSpPr txBox="1"/>
+          <p:nvPr/>
+        </p:nvSpPr>
+        <p:spPr>
+          <a:xfrm>
+            <a:off x="11430000" y="6446520"/>
+            <a:ext cx="640080" cy="365760"/>
+          </a:xfrm>
+          <a:prstGeom prst="rect">
+            <a:avLst/>
+          </a:prstGeom>
+          <a:noFill/>
+        </p:spPr>
+        <p:txBody>
+          <a:bodyPr wrap="square">
+            <a:spAutoFit/>
+          </a:bodyPr>
+          <a:lstStyle/>
+          <a:p>
+            <a:r>
+              <a:rPr sz="1100" b="0">
+                <a:solidFill>
+                  <a:srgbClr val="6E7781"/>
+                </a:solidFill>
+              </a:rPr>
+              <a:t>6</a:t>
+            </a:r>
+          </a:p>
+        </p:txBody>
+      </p:sp>
     </p:spTree>
   </p:cSld>
   <p:clrMapOvr>
@@ -4881,7 +5932,7 @@
 </p:sld>
 </file>
 
-<file path=ppt/slides/slide6.xml><?xml version="1.0" encoding="utf-8"?>
+<file path=ppt/slides/slide7.xml><?xml version="1.0" encoding="utf-8"?>
 <p:sld xmlns:a="http://schemas.openxmlformats.org/drawingml/2006/main" xmlns:p="http://schemas.openxmlformats.org/presentationml/2006/main" xmlns:r="http://schemas.openxmlformats.org/officeDocument/2006/relationships">
   <p:cSld>
     <p:spTree>
@@ -4893,7 +5944,7 @@
       <p:grpSpPr/>
       <p:pic>
         <p:nvPicPr>
-          <p:cNvPr id="2" name="Picture 1" descr="slide_05_seasons.png"/>
+          <p:cNvPr id="2" name="Picture 1" descr="slide_07_seasons.png"/>
           <p:cNvPicPr>
             <a:picLocks noChangeAspect="1"/>
           </p:cNvPicPr>
@@ -4915,6 +5966,39 @@
           </a:prstGeom>
         </p:spPr>
       </p:pic>
+      <p:sp>
+        <p:nvSpPr>
+          <p:cNvPr id="3" name="TextBox 2"/>
+          <p:cNvSpPr txBox="1"/>
+          <p:nvPr/>
+        </p:nvSpPr>
+        <p:spPr>
+          <a:xfrm>
+            <a:off x="11430000" y="6446520"/>
+            <a:ext cx="640080" cy="365760"/>
+          </a:xfrm>
+          <a:prstGeom prst="rect">
+            <a:avLst/>
+          </a:prstGeom>
+          <a:noFill/>
+        </p:spPr>
+        <p:txBody>
+          <a:bodyPr wrap="square">
+            <a:spAutoFit/>
+          </a:bodyPr>
+          <a:lstStyle/>
+          <a:p>
+            <a:r>
+              <a:rPr sz="1100" b="0">
+                <a:solidFill>
+                  <a:srgbClr val="6E7781"/>
+                </a:solidFill>
+              </a:rPr>
+              <a:t>7</a:t>
+            </a:r>
+          </a:p>
+        </p:txBody>
+      </p:sp>
     </p:spTree>
   </p:cSld>
   <p:clrMapOvr>
@@ -4923,7 +6007,7 @@
 </p:sld>
 </file>
 
-<file path=ppt/slides/slide7.xml><?xml version="1.0" encoding="utf-8"?>
+<file path=ppt/slides/slide8.xml><?xml version="1.0" encoding="utf-8"?>
 <p:sld xmlns:a="http://schemas.openxmlformats.org/drawingml/2006/main" xmlns:p="http://schemas.openxmlformats.org/presentationml/2006/main" xmlns:r="http://schemas.openxmlformats.org/officeDocument/2006/relationships">
   <p:cSld>
     <p:spTree>
@@ -4935,7 +6019,7 @@
       <p:grpSpPr/>
       <p:pic>
         <p:nvPicPr>
-          <p:cNvPr id="2" name="Picture 1" descr="slide_06_hottest_years.png"/>
+          <p:cNvPr id="2" name="Picture 1" descr="slide_08_hottest_years.png"/>
           <p:cNvPicPr>
             <a:picLocks noChangeAspect="1"/>
           </p:cNvPicPr>
@@ -4957,48 +6041,39 @@
           </a:prstGeom>
         </p:spPr>
       </p:pic>
-    </p:spTree>
-  </p:cSld>
-  <p:clrMapOvr>
-    <a:masterClrMapping/>
-  </p:clrMapOvr>
-</p:sld>
-</file>
-
-<file path=ppt/slides/slide8.xml><?xml version="1.0" encoding="utf-8"?>
-<p:sld xmlns:a="http://schemas.openxmlformats.org/drawingml/2006/main" xmlns:p="http://schemas.openxmlformats.org/presentationml/2006/main" xmlns:r="http://schemas.openxmlformats.org/officeDocument/2006/relationships">
-  <p:cSld>
-    <p:spTree>
-      <p:nvGrpSpPr>
-        <p:cNvPr id="1" name=""/>
-        <p:cNvGrpSpPr/>
-        <p:nvPr/>
-      </p:nvGrpSpPr>
-      <p:grpSpPr/>
-      <p:pic>
-        <p:nvPicPr>
-          <p:cNvPr id="2" name="Picture 1" descr="slide_07_coefficients.png"/>
-          <p:cNvPicPr>
-            <a:picLocks noChangeAspect="1"/>
-          </p:cNvPicPr>
+      <p:sp>
+        <p:nvSpPr>
+          <p:cNvPr id="3" name="TextBox 2"/>
+          <p:cNvSpPr txBox="1"/>
           <p:nvPr/>
-        </p:nvPicPr>
-        <p:blipFill>
-          <a:blip r:embed="rId2"/>
-          <a:stretch>
-            <a:fillRect/>
-          </a:stretch>
-        </p:blipFill>
+        </p:nvSpPr>
         <p:spPr>
           <a:xfrm>
-            <a:off x="0" y="175191"/>
-            <a:ext cx="12188952" cy="6507617"/>
+            <a:off x="11430000" y="6446520"/>
+            <a:ext cx="640080" cy="365760"/>
           </a:xfrm>
           <a:prstGeom prst="rect">
             <a:avLst/>
           </a:prstGeom>
+          <a:noFill/>
         </p:spPr>
-      </p:pic>
+        <p:txBody>
+          <a:bodyPr wrap="square">
+            <a:spAutoFit/>
+          </a:bodyPr>
+          <a:lstStyle/>
+          <a:p>
+            <a:r>
+              <a:rPr sz="1100" b="0">
+                <a:solidFill>
+                  <a:srgbClr val="6E7781"/>
+                </a:solidFill>
+              </a:rPr>
+              <a:t>8</a:t>
+            </a:r>
+          </a:p>
+        </p:txBody>
+      </p:sp>
     </p:spTree>
   </p:cSld>
   <p:clrMapOvr>
@@ -5017,16 +6092,40 @@
         <p:nvPr/>
       </p:nvGrpSpPr>
       <p:grpSpPr/>
-      <p:sp>
-        <p:nvSpPr>
-          <p:cNvPr id="2" name="TextBox 1"/>
+      <p:pic>
+        <p:nvPicPr>
+          <p:cNvPr id="2" name="Picture 1" descr="slide_09_coefficients.png"/>
+          <p:cNvPicPr>
+            <a:picLocks noChangeAspect="1"/>
+          </p:cNvPicPr>
+          <p:nvPr/>
+        </p:nvPicPr>
+        <p:blipFill>
+          <a:blip r:embed="rId2"/>
+          <a:stretch>
+            <a:fillRect/>
+          </a:stretch>
+        </p:blipFill>
+        <p:spPr>
+          <a:xfrm>
+            <a:off x="0" y="308029"/>
+            <a:ext cx="12188952" cy="6241942"/>
+          </a:xfrm>
+          <a:prstGeom prst="rect">
+            <a:avLst/>
+          </a:prstGeom>
+        </p:spPr>
+      </p:pic>
+      <p:sp>
+        <p:nvSpPr>
+          <p:cNvPr id="3" name="TextBox 2"/>
           <p:cNvSpPr txBox="1"/>
           <p:nvPr/>
         </p:nvSpPr>
         <p:spPr>
           <a:xfrm>
-            <a:off x="548640" y="457200"/>
-            <a:ext cx="10972800" cy="1097280"/>
+            <a:off x="11430000" y="6446520"/>
+            <a:ext cx="640080" cy="365760"/>
           </a:xfrm>
           <a:prstGeom prst="rect">
             <a:avLst/>
@@ -5040,64 +6139,12 @@
           <a:lstStyle/>
           <a:p>
             <a:r>
-              <a:rPr sz="3400" b="1"/>
-              <a:t>What we can and cannot conclude</a:t>
-            </a:r>
-          </a:p>
-        </p:txBody>
-      </p:sp>
-      <p:sp>
-        <p:nvSpPr>
-          <p:cNvPr id="3" name="TextBox 2"/>
-          <p:cNvSpPr txBox="1"/>
-          <p:nvPr/>
-        </p:nvSpPr>
-        <p:spPr>
-          <a:xfrm>
-            <a:off x="731520" y="1737360"/>
-            <a:ext cx="10789920" cy="4572000"/>
-          </a:xfrm>
-          <a:prstGeom prst="rect">
-            <a:avLst/>
-          </a:prstGeom>
-          <a:noFill/>
-        </p:spPr>
-        <p:txBody>
-          <a:bodyPr wrap="square">
-            <a:spAutoFit/>
-          </a:bodyPr>
-          <a:lstStyle/>
-          <a:p>
-            <a:pPr>
-              <a:spcAft>
-                <a:spcPts val="1400"/>
-              </a:spcAft>
-              <a:defRPr sz="2100"/>
-            </a:pPr>
-            <a:r>
-              <a:t>Description (solid): every country has warmed; the change exceeds year-to-year noise in 11/12. Rainfall change is mostly within the noise (0/12 beyond 2σ).</a:t>
-            </a:r>
-          </a:p>
-          <a:p>
-            <a:pPr>
-              <a:spcAft>
-                <a:spcPts val="1400"/>
-              </a:spcAft>
-              <a:defRPr sz="2100"/>
-            </a:pPr>
-            <a:r>
-              <a:t>Correlation (weak): unusually warm years go with slightly lower growth and lower crop output, but 12 countries cannot distinguish this from zero.</a:t>
-            </a:r>
-          </a:p>
-          <a:p>
-            <a:pPr>
-              <a:spcAft>
-                <a:spcPts val="1400"/>
-              </a:spcAft>
-              <a:defRPr sz="2100"/>
-            </a:pPr>
-            <a:r>
-              <a:t>Not causal, not climate change: year-to-year weather is not a permanent shift; adaptation and national aggregation hide local losses. Causality would need sub-national data, many more countries and a pre-specified exposure channel.</a:t>
+              <a:rPr sz="1100" b="0">
+                <a:solidFill>
+                  <a:srgbClr val="6E7781"/>
+                </a:solidFill>
+              </a:rPr>
+              <a:t>9</a:t>
             </a:r>
           </a:p>
         </p:txBody>

</xml_diff>